<commit_message>
feat(docs): update SDK documentation links and improve deck service functionality
- Updated documentation links in SDK type aliases and functions to reflect the latest commit hash for accurate references.
- Enhanced the deck service to infer dimensions from shared styles, improving PDF export quality.
- Introduced a mechanism to ensure print frames are ready before generating PDFs, preventing blank pages during export.
- Added a classification function for PPTX validation issues to provide clearer feedback on deck verification.

Co-authored-by: Cursor <cursoragent@cursor.com>
</commit_message>
<xml_diff>
--- a/apps/deck/exports/getdesign-deck.pptx
+++ b/apps/deck/exports/getdesign-deck.pptx
@@ -11747,7 +11747,7 @@
         </p:nvSpPr>
         <p:spPr>
           <a:xfrm>
-            <a:off x="685800" y="720775"/>
+            <a:off x="685800" y="711250"/>
             <a:ext cx="101501" cy="101501"/>
           </a:xfrm>
           <a:prstGeom prst="roundRect">
@@ -11780,7 +11780,7 @@
         <p:spPr>
           <a:xfrm>
             <a:off x="888802" y="685800"/>
-            <a:ext cx="905970" cy="171450"/>
+            <a:ext cx="908399" cy="152400"/>
           </a:xfrm>
           <a:prstGeom prst="rect">
             <a:avLst/>
@@ -11820,8 +11820,8 @@
         </p:nvSpPr>
         <p:spPr>
           <a:xfrm>
-            <a:off x="10815340" y="685800"/>
-            <a:ext cx="704677" cy="171450"/>
+            <a:off x="10813405" y="685800"/>
+            <a:ext cx="706651" cy="152400"/>
           </a:xfrm>
           <a:prstGeom prst="rect">
             <a:avLst/>
@@ -11861,8 +11861,8 @@
         </p:nvSpPr>
         <p:spPr>
           <a:xfrm>
-            <a:off x="685800" y="1536650"/>
-            <a:ext cx="1196525" cy="180975"/>
+            <a:off x="685800" y="1527125"/>
+            <a:ext cx="1200623" cy="161925"/>
           </a:xfrm>
           <a:prstGeom prst="rect">
             <a:avLst/>
@@ -11902,8 +11902,8 @@
         </p:nvSpPr>
         <p:spPr>
           <a:xfrm>
-            <a:off x="2087463" y="1269950"/>
-            <a:ext cx="8130963" cy="533400"/>
+            <a:off x="2091482" y="1269950"/>
+            <a:ext cx="7462870" cy="476250"/>
           </a:xfrm>
           <a:prstGeom prst="rect">
             <a:avLst/>
@@ -11941,7 +11941,7 @@
         </p:nvSpPr>
         <p:spPr>
           <a:xfrm>
-            <a:off x="685800" y="1930301"/>
+            <a:off x="685800" y="1873151"/>
             <a:ext cx="7772400" cy="476250"/>
           </a:xfrm>
           <a:prstGeom prst="rect">
@@ -11989,7 +11989,7 @@
         <p:spPr>
           <a:xfrm>
             <a:off x="685800" y="2920901"/>
-            <a:ext cx="5295900" cy="3297734"/>
+            <a:ext cx="5295900" cy="3126284"/>
           </a:xfrm>
           <a:prstGeom prst="rect">
             <a:avLst/>
@@ -12041,7 +12041,7 @@
         </p:nvSpPr>
         <p:spPr>
           <a:xfrm>
-            <a:off x="965150" y="3251002"/>
+            <a:off x="965150" y="3236714"/>
             <a:ext cx="203150" cy="203150"/>
           </a:xfrm>
           <a:prstGeom prst="roundRect">
@@ -12077,8 +12077,8 @@
         </p:nvSpPr>
         <p:spPr>
           <a:xfrm>
-            <a:off x="1024830" y="3282702"/>
-            <a:ext cx="85466" cy="139750"/>
+            <a:off x="1024682" y="3268414"/>
+            <a:ext cx="85618" cy="139750"/>
           </a:xfrm>
           <a:prstGeom prst="rect">
             <a:avLst/>
@@ -12120,7 +12120,7 @@
         <p:spPr>
           <a:xfrm>
             <a:off x="1295251" y="3209776"/>
-            <a:ext cx="1594101" cy="285750"/>
+            <a:ext cx="1530191" cy="257175"/>
           </a:xfrm>
           <a:prstGeom prst="rect">
             <a:avLst/>
@@ -12158,8 +12158,8 @@
         </p:nvSpPr>
         <p:spPr>
           <a:xfrm>
-            <a:off x="965150" y="3571726"/>
-            <a:ext cx="4831943" cy="171450"/>
+            <a:off x="965150" y="3543151"/>
+            <a:ext cx="4831943" cy="142875"/>
           </a:xfrm>
           <a:prstGeom prst="rect">
             <a:avLst/>
@@ -12199,8 +12199,8 @@
         </p:nvSpPr>
         <p:spPr>
           <a:xfrm>
-            <a:off x="965150" y="3971776"/>
-            <a:ext cx="4737199" cy="571202"/>
+            <a:off x="965150" y="3914626"/>
+            <a:ext cx="4737199" cy="533102"/>
           </a:xfrm>
           <a:prstGeom prst="rect">
             <a:avLst/>
@@ -12229,7 +12229,7 @@
         </p:nvSpPr>
         <p:spPr>
           <a:xfrm>
-            <a:off x="1092101" y="4117628"/>
+            <a:off x="1092101" y="4041428"/>
             <a:ext cx="279350" cy="279350"/>
           </a:xfrm>
           <a:prstGeom prst="rect">
@@ -12259,8 +12259,8 @@
         </p:nvSpPr>
         <p:spPr>
           <a:xfrm>
-            <a:off x="1523851" y="4073277"/>
-            <a:ext cx="1549926" cy="180975"/>
+            <a:off x="1523851" y="4016127"/>
+            <a:ext cx="1555087" cy="161925"/>
           </a:xfrm>
           <a:prstGeom prst="rect">
             <a:avLst/>
@@ -12298,8 +12298,8 @@
         </p:nvSpPr>
         <p:spPr>
           <a:xfrm>
-            <a:off x="1523851" y="4279553"/>
-            <a:ext cx="1549926" cy="161925"/>
+            <a:off x="1523851" y="4203353"/>
+            <a:ext cx="1555087" cy="142875"/>
           </a:xfrm>
           <a:prstGeom prst="rect">
             <a:avLst/>
@@ -12342,8 +12342,8 @@
         </p:nvSpPr>
         <p:spPr>
           <a:xfrm>
-            <a:off x="965150" y="4669929"/>
-            <a:ext cx="4737199" cy="571202"/>
+            <a:off x="965150" y="4574679"/>
+            <a:ext cx="4737199" cy="533102"/>
           </a:xfrm>
           <a:prstGeom prst="rect">
             <a:avLst/>
@@ -12372,7 +12372,7 @@
         </p:nvSpPr>
         <p:spPr>
           <a:xfrm>
-            <a:off x="1092101" y="4815780"/>
+            <a:off x="1092101" y="4701480"/>
             <a:ext cx="279350" cy="279350"/>
           </a:xfrm>
           <a:prstGeom prst="rect">
@@ -12402,8 +12402,8 @@
         </p:nvSpPr>
         <p:spPr>
           <a:xfrm>
-            <a:off x="1523851" y="4771430"/>
-            <a:ext cx="1549926" cy="180975"/>
+            <a:off x="1523851" y="4676180"/>
+            <a:ext cx="1555087" cy="161925"/>
           </a:xfrm>
           <a:prstGeom prst="rect">
             <a:avLst/>
@@ -12441,8 +12441,8 @@
         </p:nvSpPr>
         <p:spPr>
           <a:xfrm>
-            <a:off x="1523851" y="4977705"/>
-            <a:ext cx="1549926" cy="161925"/>
+            <a:off x="1523851" y="4863405"/>
+            <a:ext cx="1555087" cy="142875"/>
           </a:xfrm>
           <a:prstGeom prst="rect">
             <a:avLst/>
@@ -12485,8 +12485,8 @@
         </p:nvSpPr>
         <p:spPr>
           <a:xfrm>
-            <a:off x="965150" y="5368082"/>
-            <a:ext cx="4737199" cy="571202"/>
+            <a:off x="965150" y="5234732"/>
+            <a:ext cx="4737199" cy="533102"/>
           </a:xfrm>
           <a:prstGeom prst="rect">
             <a:avLst/>
@@ -12515,7 +12515,7 @@
         </p:nvSpPr>
         <p:spPr>
           <a:xfrm>
-            <a:off x="1092101" y="5513933"/>
+            <a:off x="1092101" y="5361533"/>
             <a:ext cx="279350" cy="279350"/>
           </a:xfrm>
           <a:prstGeom prst="rect">
@@ -12545,8 +12545,8 @@
         </p:nvSpPr>
         <p:spPr>
           <a:xfrm>
-            <a:off x="1523851" y="5469582"/>
-            <a:ext cx="1549926" cy="180975"/>
+            <a:off x="1523851" y="5336232"/>
+            <a:ext cx="1555087" cy="161925"/>
           </a:xfrm>
           <a:prstGeom prst="rect">
             <a:avLst/>
@@ -12584,8 +12584,8 @@
         </p:nvSpPr>
         <p:spPr>
           <a:xfrm>
-            <a:off x="1523851" y="5675858"/>
-            <a:ext cx="1549926" cy="161925"/>
+            <a:off x="1523851" y="5523458"/>
+            <a:ext cx="1555087" cy="142875"/>
           </a:xfrm>
           <a:prstGeom prst="rect">
             <a:avLst/>
@@ -12629,7 +12629,7 @@
         <p:spPr>
           <a:xfrm>
             <a:off x="6210300" y="2920901"/>
-            <a:ext cx="5295900" cy="3297734"/>
+            <a:ext cx="5295900" cy="3126284"/>
           </a:xfrm>
           <a:prstGeom prst="rect">
             <a:avLst/>
@@ -12681,7 +12681,7 @@
         </p:nvSpPr>
         <p:spPr>
           <a:xfrm>
-            <a:off x="6489650" y="3251002"/>
+            <a:off x="6489650" y="3236714"/>
             <a:ext cx="203150" cy="203150"/>
           </a:xfrm>
           <a:prstGeom prst="roundRect">
@@ -12713,7 +12713,7 @@
         </p:nvSpPr>
         <p:spPr>
           <a:xfrm>
-            <a:off x="6549182" y="3282702"/>
+            <a:off x="6549182" y="3268414"/>
             <a:ext cx="85770" cy="139750"/>
           </a:xfrm>
           <a:prstGeom prst="rect">
@@ -12756,7 +12756,7 @@
         <p:spPr>
           <a:xfrm>
             <a:off x="6819751" y="3209776"/>
-            <a:ext cx="2102647" cy="285750"/>
+            <a:ext cx="2004885" cy="257175"/>
           </a:xfrm>
           <a:prstGeom prst="rect">
             <a:avLst/>
@@ -12794,8 +12794,8 @@
         </p:nvSpPr>
         <p:spPr>
           <a:xfrm>
-            <a:off x="6489650" y="3571726"/>
-            <a:ext cx="4831943" cy="171450"/>
+            <a:off x="6489650" y="3543151"/>
+            <a:ext cx="4831943" cy="142875"/>
           </a:xfrm>
           <a:prstGeom prst="rect">
             <a:avLst/>
@@ -12835,8 +12835,8 @@
         </p:nvSpPr>
         <p:spPr>
           <a:xfrm>
-            <a:off x="6489650" y="3971776"/>
-            <a:ext cx="4737199" cy="571202"/>
+            <a:off x="6489650" y="3914626"/>
+            <a:ext cx="4737199" cy="533102"/>
           </a:xfrm>
           <a:prstGeom prst="rect">
             <a:avLst/>
@@ -12865,7 +12865,7 @@
         </p:nvSpPr>
         <p:spPr>
           <a:xfrm>
-            <a:off x="6616601" y="4117628"/>
+            <a:off x="6616601" y="4041428"/>
             <a:ext cx="279350" cy="279350"/>
           </a:xfrm>
           <a:prstGeom prst="rect">
@@ -12895,8 +12895,8 @@
         </p:nvSpPr>
         <p:spPr>
           <a:xfrm>
-            <a:off x="7048351" y="4073277"/>
-            <a:ext cx="1180889" cy="180975"/>
+            <a:off x="7048351" y="4016127"/>
+            <a:ext cx="1184836" cy="161925"/>
           </a:xfrm>
           <a:prstGeom prst="rect">
             <a:avLst/>
@@ -12934,8 +12934,8 @@
         </p:nvSpPr>
         <p:spPr>
           <a:xfrm>
-            <a:off x="7048351" y="4279553"/>
-            <a:ext cx="1180889" cy="161925"/>
+            <a:off x="7048351" y="4203353"/>
+            <a:ext cx="1184836" cy="142875"/>
           </a:xfrm>
           <a:prstGeom prst="rect">
             <a:avLst/>
@@ -12978,8 +12978,8 @@
         </p:nvSpPr>
         <p:spPr>
           <a:xfrm>
-            <a:off x="6489650" y="4669929"/>
-            <a:ext cx="4737199" cy="571202"/>
+            <a:off x="6489650" y="4574679"/>
+            <a:ext cx="4737199" cy="533102"/>
           </a:xfrm>
           <a:prstGeom prst="rect">
             <a:avLst/>
@@ -13008,7 +13008,7 @@
         </p:nvSpPr>
         <p:spPr>
           <a:xfrm>
-            <a:off x="6616601" y="4815780"/>
+            <a:off x="6616601" y="4701480"/>
             <a:ext cx="279350" cy="279350"/>
           </a:xfrm>
           <a:prstGeom prst="rect">
@@ -13038,8 +13038,8 @@
         </p:nvSpPr>
         <p:spPr>
           <a:xfrm>
-            <a:off x="7048351" y="4771430"/>
-            <a:ext cx="1475997" cy="180975"/>
+            <a:off x="7048351" y="4676180"/>
+            <a:ext cx="1481158" cy="161925"/>
           </a:xfrm>
           <a:prstGeom prst="rect">
             <a:avLst/>
@@ -13077,8 +13077,8 @@
         </p:nvSpPr>
         <p:spPr>
           <a:xfrm>
-            <a:off x="7048351" y="4977705"/>
-            <a:ext cx="1475997" cy="161925"/>
+            <a:off x="7048351" y="4863405"/>
+            <a:ext cx="1481158" cy="142875"/>
           </a:xfrm>
           <a:prstGeom prst="rect">
             <a:avLst/>
@@ -13121,8 +13121,8 @@
         </p:nvSpPr>
         <p:spPr>
           <a:xfrm>
-            <a:off x="6489650" y="5368082"/>
-            <a:ext cx="4737199" cy="571202"/>
+            <a:off x="6489650" y="5234732"/>
+            <a:ext cx="4737199" cy="533102"/>
           </a:xfrm>
           <a:prstGeom prst="rect">
             <a:avLst/>
@@ -13151,7 +13151,7 @@
         </p:nvSpPr>
         <p:spPr>
           <a:xfrm>
-            <a:off x="6616601" y="5513933"/>
+            <a:off x="6616601" y="5361533"/>
             <a:ext cx="279350" cy="279350"/>
           </a:xfrm>
           <a:prstGeom prst="rect">
@@ -13181,8 +13181,8 @@
         </p:nvSpPr>
         <p:spPr>
           <a:xfrm>
-            <a:off x="7048351" y="5469582"/>
-            <a:ext cx="1475997" cy="180975"/>
+            <a:off x="7048351" y="5336232"/>
+            <a:ext cx="1481158" cy="161925"/>
           </a:xfrm>
           <a:prstGeom prst="rect">
             <a:avLst/>
@@ -13220,8 +13220,8 @@
         </p:nvSpPr>
         <p:spPr>
           <a:xfrm>
-            <a:off x="7048351" y="5675858"/>
-            <a:ext cx="1475997" cy="161925"/>
+            <a:off x="7048351" y="5523458"/>
+            <a:ext cx="1481158" cy="142875"/>
           </a:xfrm>
           <a:prstGeom prst="rect">
             <a:avLst/>
@@ -13264,8 +13264,8 @@
         </p:nvSpPr>
         <p:spPr>
           <a:xfrm>
-            <a:off x="685800" y="6000750"/>
-            <a:ext cx="2154564" cy="171450"/>
+            <a:off x="685800" y="6019800"/>
+            <a:ext cx="2160788" cy="152400"/>
           </a:xfrm>
           <a:prstGeom prst="rect">
             <a:avLst/>
@@ -13305,8 +13305,8 @@
         </p:nvSpPr>
         <p:spPr>
           <a:xfrm>
-            <a:off x="8433495" y="6000750"/>
-            <a:ext cx="3134160" cy="171450"/>
+            <a:off x="8425011" y="6019800"/>
+            <a:ext cx="3142812" cy="152400"/>
           </a:xfrm>
           <a:prstGeom prst="rect">
             <a:avLst/>
@@ -16557,7 +16557,7 @@
         </p:nvSpPr>
         <p:spPr>
           <a:xfrm>
-            <a:off x="685800" y="720775"/>
+            <a:off x="685800" y="711250"/>
             <a:ext cx="101501" cy="101501"/>
           </a:xfrm>
           <a:prstGeom prst="roundRect">
@@ -16590,7 +16590,7 @@
         <p:spPr>
           <a:xfrm>
             <a:off x="888802" y="685800"/>
-            <a:ext cx="905970" cy="171450"/>
+            <a:ext cx="908399" cy="152400"/>
           </a:xfrm>
           <a:prstGeom prst="rect">
             <a:avLst/>
@@ -16630,8 +16630,8 @@
         </p:nvSpPr>
         <p:spPr>
           <a:xfrm>
-            <a:off x="10815340" y="685800"/>
-            <a:ext cx="704677" cy="171450"/>
+            <a:off x="10813405" y="685800"/>
+            <a:ext cx="706651" cy="152400"/>
           </a:xfrm>
           <a:prstGeom prst="rect">
             <a:avLst/>
@@ -16819,8 +16819,8 @@
         </p:nvSpPr>
         <p:spPr>
           <a:xfrm>
-            <a:off x="685800" y="4394448"/>
-            <a:ext cx="10820400" cy="812602"/>
+            <a:off x="685800" y="4423023"/>
+            <a:ext cx="10820400" cy="784027"/>
           </a:xfrm>
           <a:prstGeom prst="rect">
             <a:avLst/>
@@ -16849,7 +16849,7 @@
         </p:nvSpPr>
         <p:spPr>
           <a:xfrm>
-            <a:off x="685800" y="4399211"/>
+            <a:off x="685800" y="4427786"/>
             <a:ext cx="10820400" cy="0"/>
           </a:xfrm>
           <a:prstGeom prst="line">
@@ -16872,8 +16872,8 @@
         </p:nvSpPr>
         <p:spPr>
           <a:xfrm>
-            <a:off x="990600" y="4657874"/>
-            <a:ext cx="139964" cy="295275"/>
+            <a:off x="990600" y="4686449"/>
+            <a:ext cx="140419" cy="266700"/>
           </a:xfrm>
           <a:prstGeom prst="rect">
             <a:avLst/>
@@ -16911,8 +16911,8 @@
         </p:nvSpPr>
         <p:spPr>
           <a:xfrm>
-            <a:off x="1305520" y="4657874"/>
-            <a:ext cx="5176540" cy="295275"/>
+            <a:off x="1305967" y="4686449"/>
+            <a:ext cx="5194301" cy="266700"/>
           </a:xfrm>
           <a:prstGeom prst="rect">
             <a:avLst/>
@@ -16980,8 +16980,8 @@
         </p:nvSpPr>
         <p:spPr>
           <a:xfrm>
-            <a:off x="9012882" y="4724549"/>
-            <a:ext cx="1869778" cy="161925"/>
+            <a:off x="9007822" y="4748361"/>
+            <a:ext cx="1874940" cy="142875"/>
           </a:xfrm>
           <a:prstGeom prst="rect">
             <a:avLst/>
@@ -17021,7 +17021,7 @@
         </p:nvSpPr>
         <p:spPr>
           <a:xfrm>
-            <a:off x="11099899" y="4754761"/>
+            <a:off x="11099899" y="4769048"/>
             <a:ext cx="101501" cy="101501"/>
           </a:xfrm>
           <a:prstGeom prst="roundRect">
@@ -17053,8 +17053,8 @@
         </p:nvSpPr>
         <p:spPr>
           <a:xfrm>
-            <a:off x="685800" y="5602337"/>
-            <a:ext cx="2348508" cy="0"/>
+            <a:off x="685800" y="5649962"/>
+            <a:ext cx="2344787" cy="0"/>
           </a:xfrm>
           <a:prstGeom prst="line">
             <a:avLst/>
@@ -17076,8 +17076,8 @@
         </p:nvSpPr>
         <p:spPr>
           <a:xfrm>
-            <a:off x="685800" y="5759500"/>
-            <a:ext cx="2395478" cy="161925"/>
+            <a:off x="685800" y="5807125"/>
+            <a:ext cx="2391683" cy="142875"/>
           </a:xfrm>
           <a:prstGeom prst="rect">
             <a:avLst/>
@@ -17117,8 +17117,8 @@
         </p:nvSpPr>
         <p:spPr>
           <a:xfrm>
-            <a:off x="685800" y="5972175"/>
-            <a:ext cx="2395478" cy="200025"/>
+            <a:off x="685800" y="6000750"/>
+            <a:ext cx="2391683" cy="171450"/>
           </a:xfrm>
           <a:prstGeom prst="rect">
             <a:avLst/>
@@ -17159,8 +17159,8 @@
         </p:nvSpPr>
         <p:spPr>
           <a:xfrm>
-            <a:off x="3212009" y="5602337"/>
-            <a:ext cx="3241625" cy="0"/>
+            <a:off x="3208288" y="5649962"/>
+            <a:ext cx="3252788" cy="0"/>
           </a:xfrm>
           <a:prstGeom prst="line">
             <a:avLst/>
@@ -17182,8 +17182,8 @@
         </p:nvSpPr>
         <p:spPr>
           <a:xfrm>
-            <a:off x="3212009" y="5759500"/>
-            <a:ext cx="3306458" cy="161925"/>
+            <a:off x="3208288" y="5807125"/>
+            <a:ext cx="3317843" cy="142875"/>
           </a:xfrm>
           <a:prstGeom prst="rect">
             <a:avLst/>
@@ -17223,8 +17223,8 @@
         </p:nvSpPr>
         <p:spPr>
           <a:xfrm>
-            <a:off x="3212009" y="5972175"/>
-            <a:ext cx="3306458" cy="200025"/>
+            <a:off x="3208288" y="6000750"/>
+            <a:ext cx="3317843" cy="171450"/>
           </a:xfrm>
           <a:prstGeom prst="rect">
             <a:avLst/>
@@ -17265,8 +17265,8 @@
         </p:nvSpPr>
         <p:spPr>
           <a:xfrm>
-            <a:off x="6631335" y="5602337"/>
-            <a:ext cx="2348508" cy="0"/>
+            <a:off x="6638776" y="5649962"/>
+            <a:ext cx="2344787" cy="0"/>
           </a:xfrm>
           <a:prstGeom prst="line">
             <a:avLst/>
@@ -17288,8 +17288,8 @@
         </p:nvSpPr>
         <p:spPr>
           <a:xfrm>
-            <a:off x="6631335" y="5759500"/>
-            <a:ext cx="2395478" cy="161925"/>
+            <a:off x="6638776" y="5807125"/>
+            <a:ext cx="2391683" cy="142875"/>
           </a:xfrm>
           <a:prstGeom prst="rect">
             <a:avLst/>
@@ -17329,8 +17329,8 @@
         </p:nvSpPr>
         <p:spPr>
           <a:xfrm>
-            <a:off x="6631335" y="5972175"/>
-            <a:ext cx="2395478" cy="200025"/>
+            <a:off x="6638776" y="6000750"/>
+            <a:ext cx="2391683" cy="171450"/>
           </a:xfrm>
           <a:prstGeom prst="rect">
             <a:avLst/>
@@ -17371,8 +17371,8 @@
         </p:nvSpPr>
         <p:spPr>
           <a:xfrm>
-            <a:off x="9157543" y="5602337"/>
-            <a:ext cx="2348508" cy="0"/>
+            <a:off x="9161264" y="5649962"/>
+            <a:ext cx="2344787" cy="0"/>
           </a:xfrm>
           <a:prstGeom prst="line">
             <a:avLst/>
@@ -17394,8 +17394,8 @@
         </p:nvSpPr>
         <p:spPr>
           <a:xfrm>
-            <a:off x="9157543" y="5759500"/>
-            <a:ext cx="2395478" cy="161925"/>
+            <a:off x="9161264" y="5807125"/>
+            <a:ext cx="2391683" cy="142875"/>
           </a:xfrm>
           <a:prstGeom prst="rect">
             <a:avLst/>
@@ -17435,8 +17435,8 @@
         </p:nvSpPr>
         <p:spPr>
           <a:xfrm>
-            <a:off x="9157543" y="5972175"/>
-            <a:ext cx="2395478" cy="200025"/>
+            <a:off x="9161264" y="6000750"/>
+            <a:ext cx="2391683" cy="171450"/>
           </a:xfrm>
           <a:prstGeom prst="rect">
             <a:avLst/>

</xml_diff>

<commit_message>
chore: use workspace:* for internal packages; refresh docs, deck export, lockfile
Co-authored-by: Cursor <cursoragent@cursor.com>
</commit_message>
<xml_diff>
--- a/apps/deck/exports/getdesign-deck.pptx
+++ b/apps/deck/exports/getdesign-deck.pptx
@@ -2915,7 +2915,7 @@
         </p:nvSpPr>
         <p:spPr>
           <a:xfrm>
-            <a:off x="685800" y="720775"/>
+            <a:off x="685800" y="711250"/>
             <a:ext cx="101501" cy="101501"/>
           </a:xfrm>
           <a:prstGeom prst="roundRect">
@@ -2948,7 +2948,7 @@
         <p:spPr>
           <a:xfrm>
             <a:off x="888802" y="685800"/>
-            <a:ext cx="905970" cy="171450"/>
+            <a:ext cx="908399" cy="152400"/>
           </a:xfrm>
           <a:prstGeom prst="rect">
             <a:avLst/>
@@ -2988,8 +2988,8 @@
         </p:nvSpPr>
         <p:spPr>
           <a:xfrm>
-            <a:off x="10815340" y="685800"/>
-            <a:ext cx="704677" cy="171450"/>
+            <a:off x="10813405" y="685800"/>
+            <a:ext cx="706651" cy="152400"/>
           </a:xfrm>
           <a:prstGeom prst="rect">
             <a:avLst/>
@@ -3029,8 +3029,8 @@
         </p:nvSpPr>
         <p:spPr>
           <a:xfrm>
-            <a:off x="685800" y="1536650"/>
-            <a:ext cx="1025592" cy="180975"/>
+            <a:off x="685800" y="1527125"/>
+            <a:ext cx="1029084" cy="161925"/>
           </a:xfrm>
           <a:prstGeom prst="rect">
             <a:avLst/>
@@ -3070,8 +3070,8 @@
         </p:nvSpPr>
         <p:spPr>
           <a:xfrm>
-            <a:off x="1919883" y="1269950"/>
-            <a:ext cx="7629096" cy="533400"/>
+            <a:off x="1923306" y="1269950"/>
+            <a:ext cx="7018234" cy="476250"/>
           </a:xfrm>
           <a:prstGeom prst="rect">
             <a:avLst/>
@@ -3109,7 +3109,7 @@
         </p:nvSpPr>
         <p:spPr>
           <a:xfrm>
-            <a:off x="685800" y="1981051"/>
+            <a:off x="685800" y="1923901"/>
             <a:ext cx="6736029" cy="495002"/>
           </a:xfrm>
           <a:prstGeom prst="rect">
@@ -3157,7 +3157,7 @@
         <p:spPr>
           <a:xfrm>
             <a:off x="685800" y="2984450"/>
-            <a:ext cx="3454301" cy="3602385"/>
+            <a:ext cx="3454301" cy="3516660"/>
           </a:xfrm>
           <a:prstGeom prst="rect">
             <a:avLst/>
@@ -3210,7 +3210,7 @@
         <p:spPr>
           <a:xfrm>
             <a:off x="965150" y="3273326"/>
-            <a:ext cx="2953512" cy="171450"/>
+            <a:ext cx="2953512" cy="142875"/>
           </a:xfrm>
           <a:prstGeom prst="rect">
             <a:avLst/>
@@ -3250,8 +3250,8 @@
         </p:nvSpPr>
         <p:spPr>
           <a:xfrm>
-            <a:off x="965150" y="3622477"/>
-            <a:ext cx="2953512" cy="571500"/>
+            <a:off x="965150" y="3593902"/>
+            <a:ext cx="2953512" cy="257175"/>
           </a:xfrm>
           <a:prstGeom prst="rect">
             <a:avLst/>
@@ -3292,7 +3292,7 @@
         </p:nvSpPr>
         <p:spPr>
           <a:xfrm>
-            <a:off x="965150" y="4422577"/>
+            <a:off x="965150" y="4079677"/>
             <a:ext cx="355550" cy="355550"/>
           </a:xfrm>
           <a:prstGeom prst="rect">
@@ -3322,7 +3322,7 @@
         </p:nvSpPr>
         <p:spPr>
           <a:xfrm>
-            <a:off x="1396901" y="4422577"/>
+            <a:off x="1396901" y="4079677"/>
             <a:ext cx="355550" cy="355550"/>
           </a:xfrm>
           <a:prstGeom prst="rect">
@@ -3352,7 +3352,7 @@
         </p:nvSpPr>
         <p:spPr>
           <a:xfrm>
-            <a:off x="1828651" y="4422577"/>
+            <a:off x="1828651" y="4079677"/>
             <a:ext cx="355550" cy="355550"/>
           </a:xfrm>
           <a:prstGeom prst="rect">
@@ -3382,7 +3382,7 @@
         </p:nvSpPr>
         <p:spPr>
           <a:xfrm>
-            <a:off x="2260402" y="4422577"/>
+            <a:off x="2260402" y="4079677"/>
             <a:ext cx="355550" cy="355550"/>
           </a:xfrm>
           <a:prstGeom prst="rect">
@@ -3412,7 +3412,7 @@
         </p:nvSpPr>
         <p:spPr>
           <a:xfrm>
-            <a:off x="2692152" y="4422577"/>
+            <a:off x="2692152" y="4079677"/>
             <a:ext cx="355550" cy="355550"/>
           </a:xfrm>
           <a:prstGeom prst="rect">
@@ -3444,7 +3444,7 @@
         </p:nvSpPr>
         <p:spPr>
           <a:xfrm>
-            <a:off x="965150" y="4955828"/>
+            <a:off x="965150" y="4612928"/>
             <a:ext cx="2953512" cy="452438"/>
           </a:xfrm>
           <a:prstGeom prst="rect">
@@ -3489,7 +3489,7 @@
         <p:spPr>
           <a:xfrm>
             <a:off x="4368701" y="2984450"/>
-            <a:ext cx="3454450" cy="3602385"/>
+            <a:ext cx="3454450" cy="3516660"/>
           </a:xfrm>
           <a:prstGeom prst="rect">
             <a:avLst/>
@@ -3542,7 +3542,7 @@
         <p:spPr>
           <a:xfrm>
             <a:off x="4648051" y="3273326"/>
-            <a:ext cx="2953664" cy="171450"/>
+            <a:ext cx="2953664" cy="142875"/>
           </a:xfrm>
           <a:prstGeom prst="rect">
             <a:avLst/>
@@ -3582,8 +3582,8 @@
         </p:nvSpPr>
         <p:spPr>
           <a:xfrm>
-            <a:off x="4648051" y="3622477"/>
-            <a:ext cx="2953664" cy="285750"/>
+            <a:off x="4648051" y="3593902"/>
+            <a:ext cx="2953664" cy="257175"/>
           </a:xfrm>
           <a:prstGeom prst="rect">
             <a:avLst/>
@@ -3624,8 +3624,8 @@
         </p:nvSpPr>
         <p:spPr>
           <a:xfrm>
-            <a:off x="4648051" y="4136827"/>
-            <a:ext cx="2895749" cy="1314301"/>
+            <a:off x="4648051" y="4079677"/>
+            <a:ext cx="2895749" cy="1285726"/>
           </a:xfrm>
           <a:prstGeom prst="rect">
             <a:avLst/>
@@ -3654,7 +3654,7 @@
         </p:nvSpPr>
         <p:spPr>
           <a:xfrm>
-            <a:off x="4800451" y="4289227"/>
+            <a:off x="4800451" y="4232077"/>
             <a:ext cx="2590949" cy="711101"/>
           </a:xfrm>
           <a:prstGeom prst="rect">
@@ -3684,8 +3684,8 @@
         </p:nvSpPr>
         <p:spPr>
           <a:xfrm>
-            <a:off x="4800451" y="5206603"/>
-            <a:ext cx="2413248" cy="12650"/>
+            <a:off x="4800451" y="5135166"/>
+            <a:ext cx="2412950" cy="12650"/>
           </a:xfrm>
           <a:prstGeom prst="rect">
             <a:avLst/>
@@ -3716,8 +3716,8 @@
         </p:nvSpPr>
         <p:spPr>
           <a:xfrm>
-            <a:off x="7315200" y="5127278"/>
-            <a:ext cx="77724" cy="171450"/>
+            <a:off x="7314902" y="5070128"/>
+            <a:ext cx="78028" cy="142875"/>
           </a:xfrm>
           <a:prstGeom prst="rect">
             <a:avLst/>
@@ -3757,7 +3757,7 @@
         </p:nvSpPr>
         <p:spPr>
           <a:xfrm>
-            <a:off x="4648051" y="5628829"/>
+            <a:off x="4648051" y="5543104"/>
             <a:ext cx="2953664" cy="678656"/>
           </a:xfrm>
           <a:prstGeom prst="rect">
@@ -3802,7 +3802,7 @@
         <p:spPr>
           <a:xfrm>
             <a:off x="8051750" y="2984450"/>
-            <a:ext cx="3454450" cy="3602385"/>
+            <a:ext cx="3454450" cy="3516660"/>
           </a:xfrm>
           <a:prstGeom prst="rect">
             <a:avLst/>
@@ -3855,7 +3855,7 @@
         <p:spPr>
           <a:xfrm>
             <a:off x="8331101" y="3273326"/>
-            <a:ext cx="2953664" cy="171450"/>
+            <a:ext cx="2953664" cy="142875"/>
           </a:xfrm>
           <a:prstGeom prst="rect">
             <a:avLst/>
@@ -3895,8 +3895,8 @@
         </p:nvSpPr>
         <p:spPr>
           <a:xfrm>
-            <a:off x="8331101" y="3622477"/>
-            <a:ext cx="2953664" cy="285750"/>
+            <a:off x="8331101" y="3593902"/>
+            <a:ext cx="2953664" cy="257175"/>
           </a:xfrm>
           <a:prstGeom prst="rect">
             <a:avLst/>
@@ -3937,7 +3937,7 @@
         </p:nvSpPr>
         <p:spPr>
           <a:xfrm>
-            <a:off x="8331101" y="4136827"/>
+            <a:off x="8331101" y="4079677"/>
             <a:ext cx="2895749" cy="12650"/>
           </a:xfrm>
           <a:prstGeom prst="rect">
@@ -3969,7 +3969,7 @@
         </p:nvSpPr>
         <p:spPr>
           <a:xfrm>
-            <a:off x="8331101" y="4250978"/>
+            <a:off x="8331101" y="4193828"/>
             <a:ext cx="1737420" cy="12650"/>
           </a:xfrm>
           <a:prstGeom prst="rect">
@@ -4001,7 +4001,7 @@
         </p:nvSpPr>
         <p:spPr>
           <a:xfrm>
-            <a:off x="8331101" y="4365129"/>
+            <a:off x="8331101" y="4307979"/>
             <a:ext cx="2895749" cy="12650"/>
           </a:xfrm>
           <a:prstGeom prst="rect">
@@ -4033,7 +4033,7 @@
         </p:nvSpPr>
         <p:spPr>
           <a:xfrm>
-            <a:off x="8331101" y="4479280"/>
+            <a:off x="8331101" y="4422130"/>
             <a:ext cx="1158180" cy="12650"/>
           </a:xfrm>
           <a:prstGeom prst="rect">
@@ -4065,7 +4065,7 @@
         </p:nvSpPr>
         <p:spPr>
           <a:xfrm>
-            <a:off x="8331101" y="4593431"/>
+            <a:off x="8331101" y="4536281"/>
             <a:ext cx="1737420" cy="12650"/>
           </a:xfrm>
           <a:prstGeom prst="rect">
@@ -4097,7 +4097,7 @@
         </p:nvSpPr>
         <p:spPr>
           <a:xfrm>
-            <a:off x="8331101" y="4707582"/>
+            <a:off x="8331101" y="4650432"/>
             <a:ext cx="2895749" cy="12650"/>
           </a:xfrm>
           <a:prstGeom prst="rect">
@@ -4129,7 +4129,7 @@
         </p:nvSpPr>
         <p:spPr>
           <a:xfrm>
-            <a:off x="8331101" y="4821734"/>
+            <a:off x="8331101" y="4764584"/>
             <a:ext cx="1158180" cy="12650"/>
           </a:xfrm>
           <a:prstGeom prst="rect">
@@ -4161,7 +4161,7 @@
         </p:nvSpPr>
         <p:spPr>
           <a:xfrm>
-            <a:off x="8331101" y="5012085"/>
+            <a:off x="8331101" y="4954935"/>
             <a:ext cx="2953664" cy="452438"/>
           </a:xfrm>
           <a:prstGeom prst="rect">
@@ -4205,8 +4205,8 @@
         </p:nvSpPr>
         <p:spPr>
           <a:xfrm>
-            <a:off x="685800" y="6000750"/>
-            <a:ext cx="1566928" cy="171450"/>
+            <a:off x="685800" y="6019800"/>
+            <a:ext cx="1571482" cy="152400"/>
           </a:xfrm>
           <a:prstGeom prst="rect">
             <a:avLst/>
@@ -4246,8 +4246,8 @@
         </p:nvSpPr>
         <p:spPr>
           <a:xfrm>
-            <a:off x="8337798" y="6000750"/>
-            <a:ext cx="3231770" cy="171450"/>
+            <a:off x="8328720" y="6019800"/>
+            <a:ext cx="3241030" cy="152400"/>
           </a:xfrm>
           <a:prstGeom prst="rect">
             <a:avLst/>
@@ -7282,7 +7282,7 @@
         </p:nvSpPr>
         <p:spPr>
           <a:xfrm>
-            <a:off x="685800" y="720775"/>
+            <a:off x="685800" y="711250"/>
             <a:ext cx="101501" cy="101501"/>
           </a:xfrm>
           <a:prstGeom prst="roundRect">
@@ -7315,7 +7315,7 @@
         <p:spPr>
           <a:xfrm>
             <a:off x="888802" y="685800"/>
-            <a:ext cx="905970" cy="171450"/>
+            <a:ext cx="908399" cy="152400"/>
           </a:xfrm>
           <a:prstGeom prst="rect">
             <a:avLst/>
@@ -7355,8 +7355,8 @@
         </p:nvSpPr>
         <p:spPr>
           <a:xfrm>
-            <a:off x="10815340" y="685800"/>
-            <a:ext cx="704677" cy="171450"/>
+            <a:off x="10813405" y="685800"/>
+            <a:ext cx="706651" cy="152400"/>
           </a:xfrm>
           <a:prstGeom prst="rect">
             <a:avLst/>
@@ -7396,8 +7396,8 @@
         </p:nvSpPr>
         <p:spPr>
           <a:xfrm>
-            <a:off x="685800" y="1536650"/>
-            <a:ext cx="940126" cy="180975"/>
+            <a:off x="685800" y="1527125"/>
+            <a:ext cx="943314" cy="161925"/>
           </a:xfrm>
           <a:prstGeom prst="rect">
             <a:avLst/>
@@ -7437,8 +7437,8 @@
         </p:nvSpPr>
         <p:spPr>
           <a:xfrm>
-            <a:off x="1836093" y="1269950"/>
-            <a:ext cx="7022637" cy="533400"/>
+            <a:off x="1839218" y="1269950"/>
+            <a:ext cx="6438189" cy="476250"/>
           </a:xfrm>
           <a:prstGeom prst="rect">
             <a:avLst/>
@@ -7476,7 +7476,7 @@
         </p:nvSpPr>
         <p:spPr>
           <a:xfrm>
-            <a:off x="685800" y="1930301"/>
+            <a:off x="685800" y="1873151"/>
             <a:ext cx="7513269" cy="441722"/>
           </a:xfrm>
           <a:prstGeom prst="rect">
@@ -7524,7 +7524,7 @@
         <p:spPr>
           <a:xfrm>
             <a:off x="685800" y="2476500"/>
-            <a:ext cx="3522166" cy="1044922"/>
+            <a:ext cx="3522166" cy="1006822"/>
           </a:xfrm>
           <a:prstGeom prst="rect">
             <a:avLst/>
@@ -7577,7 +7577,7 @@
         <p:spPr>
           <a:xfrm>
             <a:off x="888950" y="2663726"/>
-            <a:ext cx="3178183" cy="161925"/>
+            <a:ext cx="3178183" cy="142875"/>
           </a:xfrm>
           <a:prstGeom prst="rect">
             <a:avLst/>
@@ -7615,8 +7615,8 @@
         </p:nvSpPr>
         <p:spPr>
           <a:xfrm>
-            <a:off x="888950" y="2901851"/>
-            <a:ext cx="3178183" cy="209550"/>
+            <a:off x="888950" y="2882801"/>
+            <a:ext cx="3178183" cy="190500"/>
           </a:xfrm>
           <a:prstGeom prst="rect">
             <a:avLst/>
@@ -7657,7 +7657,7 @@
         </p:nvSpPr>
         <p:spPr>
           <a:xfrm>
-            <a:off x="888950" y="3174802"/>
+            <a:off x="888950" y="3136702"/>
             <a:ext cx="3178183" cy="168920"/>
           </a:xfrm>
           <a:prstGeom prst="rect">
@@ -7705,7 +7705,7 @@
         <p:spPr>
           <a:xfrm>
             <a:off x="4334917" y="2476500"/>
-            <a:ext cx="3522166" cy="1044922"/>
+            <a:ext cx="3522166" cy="1006822"/>
           </a:xfrm>
           <a:prstGeom prst="rect">
             <a:avLst/>
@@ -7758,7 +7758,7 @@
         <p:spPr>
           <a:xfrm>
             <a:off x="4538067" y="2663726"/>
-            <a:ext cx="3178183" cy="161925"/>
+            <a:ext cx="3178183" cy="142875"/>
           </a:xfrm>
           <a:prstGeom prst="rect">
             <a:avLst/>
@@ -7796,8 +7796,8 @@
         </p:nvSpPr>
         <p:spPr>
           <a:xfrm>
-            <a:off x="4538067" y="2901851"/>
-            <a:ext cx="3178183" cy="209550"/>
+            <a:off x="4538067" y="2882801"/>
+            <a:ext cx="3178183" cy="190500"/>
           </a:xfrm>
           <a:prstGeom prst="rect">
             <a:avLst/>
@@ -7838,7 +7838,7 @@
         </p:nvSpPr>
         <p:spPr>
           <a:xfrm>
-            <a:off x="4538067" y="3174802"/>
+            <a:off x="4538067" y="3136702"/>
             <a:ext cx="3178183" cy="168920"/>
           </a:xfrm>
           <a:prstGeom prst="rect">
@@ -7886,7 +7886,7 @@
         <p:spPr>
           <a:xfrm>
             <a:off x="7984034" y="2476500"/>
-            <a:ext cx="3522166" cy="1044922"/>
+            <a:ext cx="3522166" cy="1006822"/>
           </a:xfrm>
           <a:prstGeom prst="rect">
             <a:avLst/>
@@ -7939,7 +7939,7 @@
         <p:spPr>
           <a:xfrm>
             <a:off x="8187184" y="2663726"/>
-            <a:ext cx="3178183" cy="161925"/>
+            <a:ext cx="3178183" cy="142875"/>
           </a:xfrm>
           <a:prstGeom prst="rect">
             <a:avLst/>
@@ -7977,8 +7977,8 @@
         </p:nvSpPr>
         <p:spPr>
           <a:xfrm>
-            <a:off x="8187184" y="2901851"/>
-            <a:ext cx="3178183" cy="209550"/>
+            <a:off x="8187184" y="2882801"/>
+            <a:ext cx="3178183" cy="190500"/>
           </a:xfrm>
           <a:prstGeom prst="rect">
             <a:avLst/>
@@ -8019,7 +8019,7 @@
         </p:nvSpPr>
         <p:spPr>
           <a:xfrm>
-            <a:off x="8187184" y="3174802"/>
+            <a:off x="8187184" y="3136702"/>
             <a:ext cx="3178183" cy="168920"/>
           </a:xfrm>
           <a:prstGeom prst="rect">
@@ -8066,8 +8066,8 @@
         </p:nvSpPr>
         <p:spPr>
           <a:xfrm>
-            <a:off x="685800" y="3648373"/>
-            <a:ext cx="3522166" cy="1044922"/>
+            <a:off x="685800" y="3610273"/>
+            <a:ext cx="3522166" cy="1006822"/>
           </a:xfrm>
           <a:prstGeom prst="rect">
             <a:avLst/>
@@ -8096,7 +8096,7 @@
         </p:nvSpPr>
         <p:spPr>
           <a:xfrm>
-            <a:off x="685800" y="3653135"/>
+            <a:off x="685800" y="3615035"/>
             <a:ext cx="3522166" cy="0"/>
           </a:xfrm>
           <a:prstGeom prst="line">
@@ -8119,8 +8119,8 @@
         </p:nvSpPr>
         <p:spPr>
           <a:xfrm>
-            <a:off x="888950" y="3835598"/>
-            <a:ext cx="3178183" cy="161925"/>
+            <a:off x="888950" y="3797498"/>
+            <a:ext cx="3178183" cy="142875"/>
           </a:xfrm>
           <a:prstGeom prst="rect">
             <a:avLst/>
@@ -8158,8 +8158,8 @@
         </p:nvSpPr>
         <p:spPr>
           <a:xfrm>
-            <a:off x="888950" y="4073723"/>
-            <a:ext cx="3178183" cy="209550"/>
+            <a:off x="888950" y="4016573"/>
+            <a:ext cx="3178183" cy="190500"/>
           </a:xfrm>
           <a:prstGeom prst="rect">
             <a:avLst/>
@@ -8200,7 +8200,7 @@
         </p:nvSpPr>
         <p:spPr>
           <a:xfrm>
-            <a:off x="888950" y="4346674"/>
+            <a:off x="888950" y="4270474"/>
             <a:ext cx="3178183" cy="168920"/>
           </a:xfrm>
           <a:prstGeom prst="rect">
@@ -8247,8 +8247,8 @@
         </p:nvSpPr>
         <p:spPr>
           <a:xfrm>
-            <a:off x="4334917" y="3648373"/>
-            <a:ext cx="3522166" cy="1044922"/>
+            <a:off x="4334917" y="3610273"/>
+            <a:ext cx="3522166" cy="1006822"/>
           </a:xfrm>
           <a:prstGeom prst="rect">
             <a:avLst/>
@@ -8277,7 +8277,7 @@
         </p:nvSpPr>
         <p:spPr>
           <a:xfrm>
-            <a:off x="4334917" y="3653135"/>
+            <a:off x="4334917" y="3615035"/>
             <a:ext cx="3522166" cy="0"/>
           </a:xfrm>
           <a:prstGeom prst="line">
@@ -8300,8 +8300,8 @@
         </p:nvSpPr>
         <p:spPr>
           <a:xfrm>
-            <a:off x="4538067" y="3835598"/>
-            <a:ext cx="3178183" cy="161925"/>
+            <a:off x="4538067" y="3797498"/>
+            <a:ext cx="3178183" cy="142875"/>
           </a:xfrm>
           <a:prstGeom prst="rect">
             <a:avLst/>
@@ -8339,8 +8339,8 @@
         </p:nvSpPr>
         <p:spPr>
           <a:xfrm>
-            <a:off x="4538067" y="4073723"/>
-            <a:ext cx="3178183" cy="209550"/>
+            <a:off x="4538067" y="4016573"/>
+            <a:ext cx="3178183" cy="190500"/>
           </a:xfrm>
           <a:prstGeom prst="rect">
             <a:avLst/>
@@ -8381,7 +8381,7 @@
         </p:nvSpPr>
         <p:spPr>
           <a:xfrm>
-            <a:off x="4538067" y="4346674"/>
+            <a:off x="4538067" y="4270474"/>
             <a:ext cx="3178183" cy="168920"/>
           </a:xfrm>
           <a:prstGeom prst="rect">
@@ -8428,8 +8428,8 @@
         </p:nvSpPr>
         <p:spPr>
           <a:xfrm>
-            <a:off x="7984034" y="3648373"/>
-            <a:ext cx="3522166" cy="1044922"/>
+            <a:off x="7984034" y="3610273"/>
+            <a:ext cx="3522166" cy="1006822"/>
           </a:xfrm>
           <a:prstGeom prst="rect">
             <a:avLst/>
@@ -8458,7 +8458,7 @@
         </p:nvSpPr>
         <p:spPr>
           <a:xfrm>
-            <a:off x="7984034" y="3653135"/>
+            <a:off x="7984034" y="3615035"/>
             <a:ext cx="3522166" cy="0"/>
           </a:xfrm>
           <a:prstGeom prst="line">
@@ -8481,8 +8481,8 @@
         </p:nvSpPr>
         <p:spPr>
           <a:xfrm>
-            <a:off x="8187184" y="3835598"/>
-            <a:ext cx="3178183" cy="161925"/>
+            <a:off x="8187184" y="3797498"/>
+            <a:ext cx="3178183" cy="142875"/>
           </a:xfrm>
           <a:prstGeom prst="rect">
             <a:avLst/>
@@ -8520,8 +8520,8 @@
         </p:nvSpPr>
         <p:spPr>
           <a:xfrm>
-            <a:off x="8187184" y="4073723"/>
-            <a:ext cx="3178183" cy="209550"/>
+            <a:off x="8187184" y="4016573"/>
+            <a:ext cx="3178183" cy="190500"/>
           </a:xfrm>
           <a:prstGeom prst="rect">
             <a:avLst/>
@@ -8562,7 +8562,7 @@
         </p:nvSpPr>
         <p:spPr>
           <a:xfrm>
-            <a:off x="8187184" y="4346674"/>
+            <a:off x="8187184" y="4270474"/>
             <a:ext cx="3178183" cy="168920"/>
           </a:xfrm>
           <a:prstGeom prst="rect">
@@ -8609,8 +8609,8 @@
         </p:nvSpPr>
         <p:spPr>
           <a:xfrm>
-            <a:off x="685800" y="4820245"/>
-            <a:ext cx="3522166" cy="1044922"/>
+            <a:off x="685800" y="4744045"/>
+            <a:ext cx="3522166" cy="1006822"/>
           </a:xfrm>
           <a:prstGeom prst="rect">
             <a:avLst/>
@@ -8639,7 +8639,7 @@
         </p:nvSpPr>
         <p:spPr>
           <a:xfrm>
-            <a:off x="685800" y="4825008"/>
+            <a:off x="685800" y="4748808"/>
             <a:ext cx="3522166" cy="0"/>
           </a:xfrm>
           <a:prstGeom prst="line">
@@ -8662,8 +8662,8 @@
         </p:nvSpPr>
         <p:spPr>
           <a:xfrm>
-            <a:off x="888950" y="5007471"/>
-            <a:ext cx="3178183" cy="161925"/>
+            <a:off x="888950" y="4931271"/>
+            <a:ext cx="3178183" cy="142875"/>
           </a:xfrm>
           <a:prstGeom prst="rect">
             <a:avLst/>
@@ -8701,8 +8701,8 @@
         </p:nvSpPr>
         <p:spPr>
           <a:xfrm>
-            <a:off x="888950" y="5245596"/>
-            <a:ext cx="3178183" cy="209550"/>
+            <a:off x="888950" y="5150346"/>
+            <a:ext cx="3178183" cy="190500"/>
           </a:xfrm>
           <a:prstGeom prst="rect">
             <a:avLst/>
@@ -8743,7 +8743,7 @@
         </p:nvSpPr>
         <p:spPr>
           <a:xfrm>
-            <a:off x="888950" y="5518547"/>
+            <a:off x="888950" y="5404247"/>
             <a:ext cx="3178183" cy="168920"/>
           </a:xfrm>
           <a:prstGeom prst="rect">
@@ -8790,8 +8790,8 @@
         </p:nvSpPr>
         <p:spPr>
           <a:xfrm>
-            <a:off x="4334917" y="4820245"/>
-            <a:ext cx="3522166" cy="1044922"/>
+            <a:off x="4334917" y="4744045"/>
+            <a:ext cx="3522166" cy="1006822"/>
           </a:xfrm>
           <a:prstGeom prst="rect">
             <a:avLst/>
@@ -8820,7 +8820,7 @@
         </p:nvSpPr>
         <p:spPr>
           <a:xfrm>
-            <a:off x="4334917" y="4825008"/>
+            <a:off x="4334917" y="4748808"/>
             <a:ext cx="3522166" cy="0"/>
           </a:xfrm>
           <a:prstGeom prst="line">
@@ -8843,8 +8843,8 @@
         </p:nvSpPr>
         <p:spPr>
           <a:xfrm>
-            <a:off x="4538067" y="5007471"/>
-            <a:ext cx="3178183" cy="161925"/>
+            <a:off x="4538067" y="4931271"/>
+            <a:ext cx="3178183" cy="142875"/>
           </a:xfrm>
           <a:prstGeom prst="rect">
             <a:avLst/>
@@ -8882,8 +8882,8 @@
         </p:nvSpPr>
         <p:spPr>
           <a:xfrm>
-            <a:off x="4538067" y="5245596"/>
-            <a:ext cx="3178183" cy="209550"/>
+            <a:off x="4538067" y="5150346"/>
+            <a:ext cx="3178183" cy="190500"/>
           </a:xfrm>
           <a:prstGeom prst="rect">
             <a:avLst/>
@@ -8924,7 +8924,7 @@
         </p:nvSpPr>
         <p:spPr>
           <a:xfrm>
-            <a:off x="4538067" y="5518547"/>
+            <a:off x="4538067" y="5404247"/>
             <a:ext cx="3178183" cy="168920"/>
           </a:xfrm>
           <a:prstGeom prst="rect">
@@ -8971,8 +8971,8 @@
         </p:nvSpPr>
         <p:spPr>
           <a:xfrm>
-            <a:off x="7984034" y="4820245"/>
-            <a:ext cx="3522166" cy="1044922"/>
+            <a:off x="7984034" y="4744045"/>
+            <a:ext cx="3522166" cy="1006822"/>
           </a:xfrm>
           <a:prstGeom prst="rect">
             <a:avLst/>
@@ -9001,7 +9001,7 @@
         </p:nvSpPr>
         <p:spPr>
           <a:xfrm>
-            <a:off x="7984034" y="4825008"/>
+            <a:off x="7984034" y="4748808"/>
             <a:ext cx="3522166" cy="0"/>
           </a:xfrm>
           <a:prstGeom prst="line">
@@ -9024,8 +9024,8 @@
         </p:nvSpPr>
         <p:spPr>
           <a:xfrm>
-            <a:off x="8187184" y="5007471"/>
-            <a:ext cx="3178183" cy="161925"/>
+            <a:off x="8187184" y="4931271"/>
+            <a:ext cx="3178183" cy="142875"/>
           </a:xfrm>
           <a:prstGeom prst="rect">
             <a:avLst/>
@@ -9063,8 +9063,8 @@
         </p:nvSpPr>
         <p:spPr>
           <a:xfrm>
-            <a:off x="8187184" y="5245596"/>
-            <a:ext cx="3178183" cy="209550"/>
+            <a:off x="8187184" y="5150346"/>
+            <a:ext cx="3178183" cy="190500"/>
           </a:xfrm>
           <a:prstGeom prst="rect">
             <a:avLst/>
@@ -9105,7 +9105,7 @@
         </p:nvSpPr>
         <p:spPr>
           <a:xfrm>
-            <a:off x="8187184" y="5518547"/>
+            <a:off x="8187184" y="5404247"/>
             <a:ext cx="3178183" cy="168920"/>
           </a:xfrm>
           <a:prstGeom prst="rect">
@@ -9152,8 +9152,8 @@
         </p:nvSpPr>
         <p:spPr>
           <a:xfrm>
-            <a:off x="685800" y="6000750"/>
-            <a:ext cx="1469014" cy="171450"/>
+            <a:off x="685800" y="6019800"/>
+            <a:ext cx="1473264" cy="152400"/>
           </a:xfrm>
           <a:prstGeom prst="rect">
             <a:avLst/>
@@ -9193,8 +9193,8 @@
         </p:nvSpPr>
         <p:spPr>
           <a:xfrm>
-            <a:off x="9201894" y="6000750"/>
-            <a:ext cx="2350392" cy="171450"/>
+            <a:off x="9195346" y="6019800"/>
+            <a:ext cx="2357071" cy="152400"/>
           </a:xfrm>
           <a:prstGeom prst="rect">
             <a:avLst/>
@@ -11747,7 +11747,7 @@
         </p:nvSpPr>
         <p:spPr>
           <a:xfrm>
-            <a:off x="685800" y="711250"/>
+            <a:off x="685800" y="720775"/>
             <a:ext cx="101501" cy="101501"/>
           </a:xfrm>
           <a:prstGeom prst="roundRect">
@@ -11780,7 +11780,7 @@
         <p:spPr>
           <a:xfrm>
             <a:off x="888802" y="685800"/>
-            <a:ext cx="908399" cy="152400"/>
+            <a:ext cx="905970" cy="171450"/>
           </a:xfrm>
           <a:prstGeom prst="rect">
             <a:avLst/>
@@ -11820,8 +11820,8 @@
         </p:nvSpPr>
         <p:spPr>
           <a:xfrm>
-            <a:off x="10813405" y="685800"/>
-            <a:ext cx="706651" cy="152400"/>
+            <a:off x="10815340" y="685800"/>
+            <a:ext cx="704677" cy="171450"/>
           </a:xfrm>
           <a:prstGeom prst="rect">
             <a:avLst/>
@@ -11861,8 +11861,8 @@
         </p:nvSpPr>
         <p:spPr>
           <a:xfrm>
-            <a:off x="685800" y="1527125"/>
-            <a:ext cx="1200623" cy="161925"/>
+            <a:off x="685800" y="1536650"/>
+            <a:ext cx="1196525" cy="180975"/>
           </a:xfrm>
           <a:prstGeom prst="rect">
             <a:avLst/>
@@ -11902,8 +11902,8 @@
         </p:nvSpPr>
         <p:spPr>
           <a:xfrm>
-            <a:off x="2091482" y="1269950"/>
-            <a:ext cx="7462870" cy="476250"/>
+            <a:off x="2087463" y="1269950"/>
+            <a:ext cx="8130963" cy="533400"/>
           </a:xfrm>
           <a:prstGeom prst="rect">
             <a:avLst/>
@@ -11941,7 +11941,7 @@
         </p:nvSpPr>
         <p:spPr>
           <a:xfrm>
-            <a:off x="685800" y="1873151"/>
+            <a:off x="685800" y="1930301"/>
             <a:ext cx="7772400" cy="476250"/>
           </a:xfrm>
           <a:prstGeom prst="rect">
@@ -11989,7 +11989,7 @@
         <p:spPr>
           <a:xfrm>
             <a:off x="685800" y="2920901"/>
-            <a:ext cx="5295900" cy="3126284"/>
+            <a:ext cx="5295900" cy="3297734"/>
           </a:xfrm>
           <a:prstGeom prst="rect">
             <a:avLst/>
@@ -12041,7 +12041,7 @@
         </p:nvSpPr>
         <p:spPr>
           <a:xfrm>
-            <a:off x="965150" y="3236714"/>
+            <a:off x="965150" y="3251002"/>
             <a:ext cx="203150" cy="203150"/>
           </a:xfrm>
           <a:prstGeom prst="roundRect">
@@ -12077,8 +12077,8 @@
         </p:nvSpPr>
         <p:spPr>
           <a:xfrm>
-            <a:off x="1024682" y="3268414"/>
-            <a:ext cx="85618" cy="139750"/>
+            <a:off x="1024830" y="3282702"/>
+            <a:ext cx="85466" cy="139750"/>
           </a:xfrm>
           <a:prstGeom prst="rect">
             <a:avLst/>
@@ -12120,7 +12120,7 @@
         <p:spPr>
           <a:xfrm>
             <a:off x="1295251" y="3209776"/>
-            <a:ext cx="1530191" cy="257175"/>
+            <a:ext cx="1594101" cy="285750"/>
           </a:xfrm>
           <a:prstGeom prst="rect">
             <a:avLst/>
@@ -12158,8 +12158,8 @@
         </p:nvSpPr>
         <p:spPr>
           <a:xfrm>
-            <a:off x="965150" y="3543151"/>
-            <a:ext cx="4831943" cy="142875"/>
+            <a:off x="965150" y="3571726"/>
+            <a:ext cx="4831943" cy="171450"/>
           </a:xfrm>
           <a:prstGeom prst="rect">
             <a:avLst/>
@@ -12199,8 +12199,8 @@
         </p:nvSpPr>
         <p:spPr>
           <a:xfrm>
-            <a:off x="965150" y="3914626"/>
-            <a:ext cx="4737199" cy="533102"/>
+            <a:off x="965150" y="3971776"/>
+            <a:ext cx="4737199" cy="571202"/>
           </a:xfrm>
           <a:prstGeom prst="rect">
             <a:avLst/>
@@ -12229,7 +12229,7 @@
         </p:nvSpPr>
         <p:spPr>
           <a:xfrm>
-            <a:off x="1092101" y="4041428"/>
+            <a:off x="1092101" y="4117628"/>
             <a:ext cx="279350" cy="279350"/>
           </a:xfrm>
           <a:prstGeom prst="rect">
@@ -12259,8 +12259,8 @@
         </p:nvSpPr>
         <p:spPr>
           <a:xfrm>
-            <a:off x="1523851" y="4016127"/>
-            <a:ext cx="1555087" cy="161925"/>
+            <a:off x="1523851" y="4073277"/>
+            <a:ext cx="1549926" cy="180975"/>
           </a:xfrm>
           <a:prstGeom prst="rect">
             <a:avLst/>
@@ -12298,8 +12298,8 @@
         </p:nvSpPr>
         <p:spPr>
           <a:xfrm>
-            <a:off x="1523851" y="4203353"/>
-            <a:ext cx="1555087" cy="142875"/>
+            <a:off x="1523851" y="4279553"/>
+            <a:ext cx="1549926" cy="161925"/>
           </a:xfrm>
           <a:prstGeom prst="rect">
             <a:avLst/>
@@ -12342,8 +12342,8 @@
         </p:nvSpPr>
         <p:spPr>
           <a:xfrm>
-            <a:off x="965150" y="4574679"/>
-            <a:ext cx="4737199" cy="533102"/>
+            <a:off x="965150" y="4669929"/>
+            <a:ext cx="4737199" cy="571202"/>
           </a:xfrm>
           <a:prstGeom prst="rect">
             <a:avLst/>
@@ -12372,7 +12372,7 @@
         </p:nvSpPr>
         <p:spPr>
           <a:xfrm>
-            <a:off x="1092101" y="4701480"/>
+            <a:off x="1092101" y="4815780"/>
             <a:ext cx="279350" cy="279350"/>
           </a:xfrm>
           <a:prstGeom prst="rect">
@@ -12402,8 +12402,8 @@
         </p:nvSpPr>
         <p:spPr>
           <a:xfrm>
-            <a:off x="1523851" y="4676180"/>
-            <a:ext cx="1555087" cy="161925"/>
+            <a:off x="1523851" y="4771430"/>
+            <a:ext cx="1549926" cy="180975"/>
           </a:xfrm>
           <a:prstGeom prst="rect">
             <a:avLst/>
@@ -12441,8 +12441,8 @@
         </p:nvSpPr>
         <p:spPr>
           <a:xfrm>
-            <a:off x="1523851" y="4863405"/>
-            <a:ext cx="1555087" cy="142875"/>
+            <a:off x="1523851" y="4977705"/>
+            <a:ext cx="1549926" cy="161925"/>
           </a:xfrm>
           <a:prstGeom prst="rect">
             <a:avLst/>
@@ -12485,8 +12485,8 @@
         </p:nvSpPr>
         <p:spPr>
           <a:xfrm>
-            <a:off x="965150" y="5234732"/>
-            <a:ext cx="4737199" cy="533102"/>
+            <a:off x="965150" y="5368082"/>
+            <a:ext cx="4737199" cy="571202"/>
           </a:xfrm>
           <a:prstGeom prst="rect">
             <a:avLst/>
@@ -12515,7 +12515,7 @@
         </p:nvSpPr>
         <p:spPr>
           <a:xfrm>
-            <a:off x="1092101" y="5361533"/>
+            <a:off x="1092101" y="5513933"/>
             <a:ext cx="279350" cy="279350"/>
           </a:xfrm>
           <a:prstGeom prst="rect">
@@ -12545,8 +12545,8 @@
         </p:nvSpPr>
         <p:spPr>
           <a:xfrm>
-            <a:off x="1523851" y="5336232"/>
-            <a:ext cx="1555087" cy="161925"/>
+            <a:off x="1523851" y="5469582"/>
+            <a:ext cx="1549926" cy="180975"/>
           </a:xfrm>
           <a:prstGeom prst="rect">
             <a:avLst/>
@@ -12584,8 +12584,8 @@
         </p:nvSpPr>
         <p:spPr>
           <a:xfrm>
-            <a:off x="1523851" y="5523458"/>
-            <a:ext cx="1555087" cy="142875"/>
+            <a:off x="1523851" y="5675858"/>
+            <a:ext cx="1549926" cy="161925"/>
           </a:xfrm>
           <a:prstGeom prst="rect">
             <a:avLst/>
@@ -12629,7 +12629,7 @@
         <p:spPr>
           <a:xfrm>
             <a:off x="6210300" y="2920901"/>
-            <a:ext cx="5295900" cy="3126284"/>
+            <a:ext cx="5295900" cy="3297734"/>
           </a:xfrm>
           <a:prstGeom prst="rect">
             <a:avLst/>
@@ -12681,7 +12681,7 @@
         </p:nvSpPr>
         <p:spPr>
           <a:xfrm>
-            <a:off x="6489650" y="3236714"/>
+            <a:off x="6489650" y="3251002"/>
             <a:ext cx="203150" cy="203150"/>
           </a:xfrm>
           <a:prstGeom prst="roundRect">
@@ -12713,7 +12713,7 @@
         </p:nvSpPr>
         <p:spPr>
           <a:xfrm>
-            <a:off x="6549182" y="3268414"/>
+            <a:off x="6549182" y="3282702"/>
             <a:ext cx="85770" cy="139750"/>
           </a:xfrm>
           <a:prstGeom prst="rect">
@@ -12756,7 +12756,7 @@
         <p:spPr>
           <a:xfrm>
             <a:off x="6819751" y="3209776"/>
-            <a:ext cx="2004885" cy="257175"/>
+            <a:ext cx="2102647" cy="285750"/>
           </a:xfrm>
           <a:prstGeom prst="rect">
             <a:avLst/>
@@ -12794,8 +12794,8 @@
         </p:nvSpPr>
         <p:spPr>
           <a:xfrm>
-            <a:off x="6489650" y="3543151"/>
-            <a:ext cx="4831943" cy="142875"/>
+            <a:off x="6489650" y="3571726"/>
+            <a:ext cx="4831943" cy="171450"/>
           </a:xfrm>
           <a:prstGeom prst="rect">
             <a:avLst/>
@@ -12835,8 +12835,8 @@
         </p:nvSpPr>
         <p:spPr>
           <a:xfrm>
-            <a:off x="6489650" y="3914626"/>
-            <a:ext cx="4737199" cy="533102"/>
+            <a:off x="6489650" y="3971776"/>
+            <a:ext cx="4737199" cy="571202"/>
           </a:xfrm>
           <a:prstGeom prst="rect">
             <a:avLst/>
@@ -12865,7 +12865,7 @@
         </p:nvSpPr>
         <p:spPr>
           <a:xfrm>
-            <a:off x="6616601" y="4041428"/>
+            <a:off x="6616601" y="4117628"/>
             <a:ext cx="279350" cy="279350"/>
           </a:xfrm>
           <a:prstGeom prst="rect">
@@ -12895,8 +12895,8 @@
         </p:nvSpPr>
         <p:spPr>
           <a:xfrm>
-            <a:off x="7048351" y="4016127"/>
-            <a:ext cx="1184836" cy="161925"/>
+            <a:off x="7048351" y="4073277"/>
+            <a:ext cx="1180889" cy="180975"/>
           </a:xfrm>
           <a:prstGeom prst="rect">
             <a:avLst/>
@@ -12934,8 +12934,8 @@
         </p:nvSpPr>
         <p:spPr>
           <a:xfrm>
-            <a:off x="7048351" y="4203353"/>
-            <a:ext cx="1184836" cy="142875"/>
+            <a:off x="7048351" y="4279553"/>
+            <a:ext cx="1180889" cy="161925"/>
           </a:xfrm>
           <a:prstGeom prst="rect">
             <a:avLst/>
@@ -12978,8 +12978,8 @@
         </p:nvSpPr>
         <p:spPr>
           <a:xfrm>
-            <a:off x="6489650" y="4574679"/>
-            <a:ext cx="4737199" cy="533102"/>
+            <a:off x="6489650" y="4669929"/>
+            <a:ext cx="4737199" cy="571202"/>
           </a:xfrm>
           <a:prstGeom prst="rect">
             <a:avLst/>
@@ -13008,7 +13008,7 @@
         </p:nvSpPr>
         <p:spPr>
           <a:xfrm>
-            <a:off x="6616601" y="4701480"/>
+            <a:off x="6616601" y="4815780"/>
             <a:ext cx="279350" cy="279350"/>
           </a:xfrm>
           <a:prstGeom prst="rect">
@@ -13038,8 +13038,8 @@
         </p:nvSpPr>
         <p:spPr>
           <a:xfrm>
-            <a:off x="7048351" y="4676180"/>
-            <a:ext cx="1481158" cy="161925"/>
+            <a:off x="7048351" y="4771430"/>
+            <a:ext cx="1475997" cy="180975"/>
           </a:xfrm>
           <a:prstGeom prst="rect">
             <a:avLst/>
@@ -13077,8 +13077,8 @@
         </p:nvSpPr>
         <p:spPr>
           <a:xfrm>
-            <a:off x="7048351" y="4863405"/>
-            <a:ext cx="1481158" cy="142875"/>
+            <a:off x="7048351" y="4977705"/>
+            <a:ext cx="1475997" cy="161925"/>
           </a:xfrm>
           <a:prstGeom prst="rect">
             <a:avLst/>
@@ -13121,8 +13121,8 @@
         </p:nvSpPr>
         <p:spPr>
           <a:xfrm>
-            <a:off x="6489650" y="5234732"/>
-            <a:ext cx="4737199" cy="533102"/>
+            <a:off x="6489650" y="5368082"/>
+            <a:ext cx="4737199" cy="571202"/>
           </a:xfrm>
           <a:prstGeom prst="rect">
             <a:avLst/>
@@ -13151,7 +13151,7 @@
         </p:nvSpPr>
         <p:spPr>
           <a:xfrm>
-            <a:off x="6616601" y="5361533"/>
+            <a:off x="6616601" y="5513933"/>
             <a:ext cx="279350" cy="279350"/>
           </a:xfrm>
           <a:prstGeom prst="rect">
@@ -13181,8 +13181,8 @@
         </p:nvSpPr>
         <p:spPr>
           <a:xfrm>
-            <a:off x="7048351" y="5336232"/>
-            <a:ext cx="1481158" cy="161925"/>
+            <a:off x="7048351" y="5469582"/>
+            <a:ext cx="1475997" cy="180975"/>
           </a:xfrm>
           <a:prstGeom prst="rect">
             <a:avLst/>
@@ -13220,8 +13220,8 @@
         </p:nvSpPr>
         <p:spPr>
           <a:xfrm>
-            <a:off x="7048351" y="5523458"/>
-            <a:ext cx="1481158" cy="142875"/>
+            <a:off x="7048351" y="5675858"/>
+            <a:ext cx="1475997" cy="161925"/>
           </a:xfrm>
           <a:prstGeom prst="rect">
             <a:avLst/>
@@ -13264,8 +13264,8 @@
         </p:nvSpPr>
         <p:spPr>
           <a:xfrm>
-            <a:off x="685800" y="6019800"/>
-            <a:ext cx="2160788" cy="152400"/>
+            <a:off x="685800" y="6000750"/>
+            <a:ext cx="2154564" cy="171450"/>
           </a:xfrm>
           <a:prstGeom prst="rect">
             <a:avLst/>
@@ -13305,8 +13305,8 @@
         </p:nvSpPr>
         <p:spPr>
           <a:xfrm>
-            <a:off x="8425011" y="6019800"/>
-            <a:ext cx="3142812" cy="152400"/>
+            <a:off x="8433495" y="6000750"/>
+            <a:ext cx="3134160" cy="171450"/>
           </a:xfrm>
           <a:prstGeom prst="rect">
             <a:avLst/>
@@ -16557,7 +16557,7 @@
         </p:nvSpPr>
         <p:spPr>
           <a:xfrm>
-            <a:off x="685800" y="711250"/>
+            <a:off x="685800" y="720775"/>
             <a:ext cx="101501" cy="101501"/>
           </a:xfrm>
           <a:prstGeom prst="roundRect">
@@ -16590,7 +16590,7 @@
         <p:spPr>
           <a:xfrm>
             <a:off x="888802" y="685800"/>
-            <a:ext cx="908399" cy="152400"/>
+            <a:ext cx="905970" cy="171450"/>
           </a:xfrm>
           <a:prstGeom prst="rect">
             <a:avLst/>
@@ -16630,8 +16630,8 @@
         </p:nvSpPr>
         <p:spPr>
           <a:xfrm>
-            <a:off x="10813405" y="685800"/>
-            <a:ext cx="706651" cy="152400"/>
+            <a:off x="10815340" y="685800"/>
+            <a:ext cx="704677" cy="171450"/>
           </a:xfrm>
           <a:prstGeom prst="rect">
             <a:avLst/>
@@ -16819,8 +16819,8 @@
         </p:nvSpPr>
         <p:spPr>
           <a:xfrm>
-            <a:off x="685800" y="4423023"/>
-            <a:ext cx="10820400" cy="784027"/>
+            <a:off x="685800" y="4394448"/>
+            <a:ext cx="10820400" cy="812602"/>
           </a:xfrm>
           <a:prstGeom prst="rect">
             <a:avLst/>
@@ -16849,7 +16849,7 @@
         </p:nvSpPr>
         <p:spPr>
           <a:xfrm>
-            <a:off x="685800" y="4427786"/>
+            <a:off x="685800" y="4399211"/>
             <a:ext cx="10820400" cy="0"/>
           </a:xfrm>
           <a:prstGeom prst="line">
@@ -16872,8 +16872,8 @@
         </p:nvSpPr>
         <p:spPr>
           <a:xfrm>
-            <a:off x="990600" y="4686449"/>
-            <a:ext cx="140419" cy="266700"/>
+            <a:off x="990600" y="4657874"/>
+            <a:ext cx="139964" cy="295275"/>
           </a:xfrm>
           <a:prstGeom prst="rect">
             <a:avLst/>
@@ -16911,8 +16911,8 @@
         </p:nvSpPr>
         <p:spPr>
           <a:xfrm>
-            <a:off x="1305967" y="4686449"/>
-            <a:ext cx="5194301" cy="266700"/>
+            <a:off x="1305520" y="4657874"/>
+            <a:ext cx="5176540" cy="295275"/>
           </a:xfrm>
           <a:prstGeom prst="rect">
             <a:avLst/>
@@ -16980,8 +16980,8 @@
         </p:nvSpPr>
         <p:spPr>
           <a:xfrm>
-            <a:off x="9007822" y="4748361"/>
-            <a:ext cx="1874940" cy="142875"/>
+            <a:off x="9012882" y="4724549"/>
+            <a:ext cx="1869778" cy="161925"/>
           </a:xfrm>
           <a:prstGeom prst="rect">
             <a:avLst/>
@@ -17021,7 +17021,7 @@
         </p:nvSpPr>
         <p:spPr>
           <a:xfrm>
-            <a:off x="11099899" y="4769048"/>
+            <a:off x="11099899" y="4754761"/>
             <a:ext cx="101501" cy="101501"/>
           </a:xfrm>
           <a:prstGeom prst="roundRect">
@@ -17053,8 +17053,8 @@
         </p:nvSpPr>
         <p:spPr>
           <a:xfrm>
-            <a:off x="685800" y="5649962"/>
-            <a:ext cx="2344787" cy="0"/>
+            <a:off x="685800" y="5602337"/>
+            <a:ext cx="2348508" cy="0"/>
           </a:xfrm>
           <a:prstGeom prst="line">
             <a:avLst/>
@@ -17076,8 +17076,8 @@
         </p:nvSpPr>
         <p:spPr>
           <a:xfrm>
-            <a:off x="685800" y="5807125"/>
-            <a:ext cx="2391683" cy="142875"/>
+            <a:off x="685800" y="5759500"/>
+            <a:ext cx="2395478" cy="161925"/>
           </a:xfrm>
           <a:prstGeom prst="rect">
             <a:avLst/>
@@ -17117,8 +17117,8 @@
         </p:nvSpPr>
         <p:spPr>
           <a:xfrm>
-            <a:off x="685800" y="6000750"/>
-            <a:ext cx="2391683" cy="171450"/>
+            <a:off x="685800" y="5972175"/>
+            <a:ext cx="2395478" cy="200025"/>
           </a:xfrm>
           <a:prstGeom prst="rect">
             <a:avLst/>
@@ -17159,8 +17159,8 @@
         </p:nvSpPr>
         <p:spPr>
           <a:xfrm>
-            <a:off x="3208288" y="5649962"/>
-            <a:ext cx="3252788" cy="0"/>
+            <a:off x="3212009" y="5602337"/>
+            <a:ext cx="3241625" cy="0"/>
           </a:xfrm>
           <a:prstGeom prst="line">
             <a:avLst/>
@@ -17182,8 +17182,8 @@
         </p:nvSpPr>
         <p:spPr>
           <a:xfrm>
-            <a:off x="3208288" y="5807125"/>
-            <a:ext cx="3317843" cy="142875"/>
+            <a:off x="3212009" y="5759500"/>
+            <a:ext cx="3306458" cy="161925"/>
           </a:xfrm>
           <a:prstGeom prst="rect">
             <a:avLst/>
@@ -17223,8 +17223,8 @@
         </p:nvSpPr>
         <p:spPr>
           <a:xfrm>
-            <a:off x="3208288" y="6000750"/>
-            <a:ext cx="3317843" cy="171450"/>
+            <a:off x="3212009" y="5972175"/>
+            <a:ext cx="3306458" cy="200025"/>
           </a:xfrm>
           <a:prstGeom prst="rect">
             <a:avLst/>
@@ -17265,8 +17265,8 @@
         </p:nvSpPr>
         <p:spPr>
           <a:xfrm>
-            <a:off x="6638776" y="5649962"/>
-            <a:ext cx="2344787" cy="0"/>
+            <a:off x="6631335" y="5602337"/>
+            <a:ext cx="2348508" cy="0"/>
           </a:xfrm>
           <a:prstGeom prst="line">
             <a:avLst/>
@@ -17288,8 +17288,8 @@
         </p:nvSpPr>
         <p:spPr>
           <a:xfrm>
-            <a:off x="6638776" y="5807125"/>
-            <a:ext cx="2391683" cy="142875"/>
+            <a:off x="6631335" y="5759500"/>
+            <a:ext cx="2395478" cy="161925"/>
           </a:xfrm>
           <a:prstGeom prst="rect">
             <a:avLst/>
@@ -17329,8 +17329,8 @@
         </p:nvSpPr>
         <p:spPr>
           <a:xfrm>
-            <a:off x="6638776" y="6000750"/>
-            <a:ext cx="2391683" cy="171450"/>
+            <a:off x="6631335" y="5972175"/>
+            <a:ext cx="2395478" cy="200025"/>
           </a:xfrm>
           <a:prstGeom prst="rect">
             <a:avLst/>
@@ -17371,8 +17371,8 @@
         </p:nvSpPr>
         <p:spPr>
           <a:xfrm>
-            <a:off x="9161264" y="5649962"/>
-            <a:ext cx="2344787" cy="0"/>
+            <a:off x="9157543" y="5602337"/>
+            <a:ext cx="2348508" cy="0"/>
           </a:xfrm>
           <a:prstGeom prst="line">
             <a:avLst/>
@@ -17394,8 +17394,8 @@
         </p:nvSpPr>
         <p:spPr>
           <a:xfrm>
-            <a:off x="9161264" y="5807125"/>
-            <a:ext cx="2391683" cy="142875"/>
+            <a:off x="9157543" y="5759500"/>
+            <a:ext cx="2395478" cy="161925"/>
           </a:xfrm>
           <a:prstGeom prst="rect">
             <a:avLst/>
@@ -17435,8 +17435,8 @@
         </p:nvSpPr>
         <p:spPr>
           <a:xfrm>
-            <a:off x="9161264" y="6000750"/>
-            <a:ext cx="2391683" cy="171450"/>
+            <a:off x="9157543" y="5972175"/>
+            <a:ext cx="2395478" cy="200025"/>
           </a:xfrm>
           <a:prstGeom prst="rect">
             <a:avLst/>

</xml_diff>